<commit_message>
style: add logo branding to cover and refine RTL alignment for slides
</commit_message>
<xml_diff>
--- a/ALMAGD_PMS_Visual_Master_Presentation.pptx
+++ b/ALMAGD_PMS_Visual_Master_Presentation.pptx
@@ -3200,16 +3200,40 @@
           </a:p>
         </p:txBody>
       </p:sp>
-      <p:sp>
-        <p:nvSpPr>
-          <p:cNvPr id="4" name="TextBox 3"/>
+      <p:pic>
+        <p:nvPicPr>
+          <p:cNvPr id="4" name="Picture 3" descr="logo-almagd-light.png"/>
+          <p:cNvPicPr>
+            <a:picLocks noChangeAspect="1"/>
+          </p:cNvPicPr>
+          <p:nvPr/>
+        </p:nvPicPr>
+        <p:blipFill>
+          <a:blip r:embed="rId2"/>
+          <a:stretch>
+            <a:fillRect/>
+          </a:stretch>
+        </p:blipFill>
+        <p:spPr>
+          <a:xfrm>
+            <a:off x="4723790" y="1051560"/>
+            <a:ext cx="2743200" cy="953691"/>
+          </a:xfrm>
+          <a:prstGeom prst="rect">
+            <a:avLst/>
+          </a:prstGeom>
+        </p:spPr>
+      </p:pic>
+      <p:sp>
+        <p:nvSpPr>
+          <p:cNvPr id="5" name="TextBox 4"/>
           <p:cNvSpPr txBox="1"/>
           <p:nvPr/>
         </p:nvSpPr>
         <p:spPr>
           <a:xfrm>
-            <a:off x="1097280" y="1280160"/>
-            <a:ext cx="9966960" cy="4389120"/>
+            <a:off x="1097280" y="2148840"/>
+            <a:ext cx="9966960" cy="3749039"/>
           </a:xfrm>
           <a:prstGeom prst="rect">
             <a:avLst/>
@@ -3223,7 +3247,7 @@
           <a:lstStyle/>
           <a:p>
             <a:pPr algn="ctr">
-              <a:defRPr sz="1500" b="1">
+              <a:defRPr sz="1400" b="1">
                 <a:solidFill>
                   <a:srgbClr val="C5A869"/>
                 </a:solidFill>
@@ -3236,7 +3260,7 @@
           </a:p>
           <a:p>
             <a:pPr algn="ctr">
-              <a:defRPr sz="3200" b="1">
+              <a:defRPr sz="3000" b="1">
                 <a:solidFill>
                   <a:srgbClr val="FFFFFF"/>
                 </a:solidFill>
@@ -3261,7 +3285,6 @@
             </a:r>
           </a:p>
           <a:p>
-            <a:br/>
             <a:br/>
             <a:pPr algn="ctr">
               <a:defRPr sz="1300" b="1">
@@ -9390,7 +9413,7 @@
         </p:nvSpPr>
         <p:spPr>
           <a:xfrm>
-            <a:off x="731520" y="1554480"/>
+            <a:off x="7955280" y="1554480"/>
             <a:ext cx="3474720" cy="1920240"/>
           </a:xfrm>
           <a:prstGeom prst="roundRect">
@@ -9435,7 +9458,7 @@
         </p:nvSpPr>
         <p:spPr>
           <a:xfrm>
-            <a:off x="868680" y="1691640"/>
+            <a:off x="8092440" y="1691640"/>
             <a:ext cx="3200400" cy="1645920"/>
           </a:xfrm>
           <a:prstGeom prst="rect">
@@ -9449,7 +9472,7 @@
           </a:bodyPr>
           <a:lstStyle/>
           <a:p>
-            <a:pPr>
+            <a:pPr algn="r">
               <a:defRPr sz="1300" b="1">
                 <a:solidFill>
                   <a:srgbClr val="0F1E36"/>
@@ -9463,7 +9486,7 @@
           </a:p>
           <a:p>
             <a:br/>
-            <a:pPr>
+            <a:pPr algn="r">
               <a:defRPr sz="1000">
                 <a:solidFill>
                   <a:srgbClr val="475569"/>
@@ -9544,7 +9567,7 @@
           </a:bodyPr>
           <a:lstStyle/>
           <a:p>
-            <a:pPr>
+            <a:pPr algn="r">
               <a:defRPr sz="1300" b="1">
                 <a:solidFill>
                   <a:srgbClr val="0F1E36"/>
@@ -9558,7 +9581,7 @@
           </a:p>
           <a:p>
             <a:br/>
-            <a:pPr>
+            <a:pPr algn="r">
               <a:defRPr sz="1000">
                 <a:solidFill>
                   <a:srgbClr val="475569"/>
@@ -9580,7 +9603,7 @@
         </p:nvSpPr>
         <p:spPr>
           <a:xfrm>
-            <a:off x="7955280" y="1554480"/>
+            <a:off x="731520" y="1554480"/>
             <a:ext cx="3474720" cy="1920240"/>
           </a:xfrm>
           <a:prstGeom prst="roundRect">
@@ -9625,7 +9648,7 @@
         </p:nvSpPr>
         <p:spPr>
           <a:xfrm>
-            <a:off x="8092440" y="1691640"/>
+            <a:off x="868680" y="1691640"/>
             <a:ext cx="3200400" cy="1645920"/>
           </a:xfrm>
           <a:prstGeom prst="rect">
@@ -9639,7 +9662,7 @@
           </a:bodyPr>
           <a:lstStyle/>
           <a:p>
-            <a:pPr>
+            <a:pPr algn="r">
               <a:defRPr sz="1300" b="1">
                 <a:solidFill>
                   <a:srgbClr val="0F1E36"/>
@@ -9653,7 +9676,7 @@
           </a:p>
           <a:p>
             <a:br/>
-            <a:pPr>
+            <a:pPr algn="r">
               <a:defRPr sz="1000">
                 <a:solidFill>
                   <a:srgbClr val="475569"/>
@@ -9675,7 +9698,7 @@
         </p:nvSpPr>
         <p:spPr>
           <a:xfrm>
-            <a:off x="731520" y="3657600"/>
+            <a:off x="7955280" y="3657600"/>
             <a:ext cx="3474720" cy="1920240"/>
           </a:xfrm>
           <a:prstGeom prst="roundRect">
@@ -9720,7 +9743,7 @@
         </p:nvSpPr>
         <p:spPr>
           <a:xfrm>
-            <a:off x="868680" y="3794760"/>
+            <a:off x="8092440" y="3794760"/>
             <a:ext cx="3200400" cy="1645920"/>
           </a:xfrm>
           <a:prstGeom prst="rect">
@@ -9734,7 +9757,7 @@
           </a:bodyPr>
           <a:lstStyle/>
           <a:p>
-            <a:pPr>
+            <a:pPr algn="r">
               <a:defRPr sz="1300" b="1">
                 <a:solidFill>
                   <a:srgbClr val="0F1E36"/>
@@ -9748,7 +9771,7 @@
           </a:p>
           <a:p>
             <a:br/>
-            <a:pPr>
+            <a:pPr algn="r">
               <a:defRPr sz="1000">
                 <a:solidFill>
                   <a:srgbClr val="475569"/>
@@ -9829,7 +9852,7 @@
           </a:bodyPr>
           <a:lstStyle/>
           <a:p>
-            <a:pPr>
+            <a:pPr algn="r">
               <a:defRPr sz="1300" b="1">
                 <a:solidFill>
                   <a:srgbClr val="0F1E36"/>
@@ -9843,7 +9866,7 @@
           </a:p>
           <a:p>
             <a:br/>
-            <a:pPr>
+            <a:pPr algn="r">
               <a:defRPr sz="1000">
                 <a:solidFill>
                   <a:srgbClr val="475569"/>
@@ -9865,7 +9888,7 @@
         </p:nvSpPr>
         <p:spPr>
           <a:xfrm>
-            <a:off x="7955280" y="3657600"/>
+            <a:off x="731520" y="3657600"/>
             <a:ext cx="3474720" cy="1920240"/>
           </a:xfrm>
           <a:prstGeom prst="roundRect">
@@ -9910,7 +9933,7 @@
         </p:nvSpPr>
         <p:spPr>
           <a:xfrm>
-            <a:off x="8092440" y="3794760"/>
+            <a:off x="868680" y="3794760"/>
             <a:ext cx="3200400" cy="1645920"/>
           </a:xfrm>
           <a:prstGeom prst="rect">
@@ -9924,7 +9947,7 @@
           </a:bodyPr>
           <a:lstStyle/>
           <a:p>
-            <a:pPr>
+            <a:pPr algn="r">
               <a:defRPr sz="1300" b="1">
                 <a:solidFill>
                   <a:srgbClr val="0F1E36"/>
@@ -9938,7 +9961,7 @@
           </a:p>
           <a:p>
             <a:br/>
-            <a:pPr>
+            <a:pPr algn="r">
               <a:defRPr sz="1000">
                 <a:solidFill>
                   <a:srgbClr val="475569"/>
@@ -12537,7 +12560,7 @@
           </a:p>
           <a:p>
             <a:br/>
-            <a:pPr>
+            <a:pPr algn="r">
               <a:defRPr sz="1200">
                 <a:solidFill>
                   <a:srgbClr val="FFFFFF"/>
@@ -12551,7 +12574,7 @@
           </a:p>
           <a:p>
             <a:br/>
-            <a:pPr>
+            <a:pPr algn="r">
               <a:defRPr sz="1200">
                 <a:solidFill>
                   <a:srgbClr val="FFFFFF"/>
@@ -12565,7 +12588,7 @@
           </a:p>
           <a:p>
             <a:br/>
-            <a:pPr>
+            <a:pPr algn="r">
               <a:defRPr sz="1200">
                 <a:solidFill>
                   <a:srgbClr val="FFFFFF"/>
@@ -12579,7 +12602,7 @@
           </a:p>
           <a:p>
             <a:br/>
-            <a:pPr>
+            <a:pPr algn="r">
               <a:defRPr sz="1200">
                 <a:solidFill>
                   <a:srgbClr val="FFFFFF"/>
@@ -12593,7 +12616,7 @@
           </a:p>
           <a:p>
             <a:br/>
-            <a:pPr>
+            <a:pPr algn="r">
               <a:defRPr sz="1200">
                 <a:solidFill>
                   <a:srgbClr val="FFFFFF"/>
@@ -12607,7 +12630,7 @@
           </a:p>
           <a:p>
             <a:br/>
-            <a:pPr>
+            <a:pPr algn="r">
               <a:defRPr sz="1200">
                 <a:solidFill>
                   <a:srgbClr val="FFFFFF"/>
@@ -12684,14 +12707,83 @@
       </p:sp>
       <p:sp>
         <p:nvSpPr>
-          <p:cNvPr id="3" name="TextBox 2"/>
+          <p:cNvPr id="3" name="Rounded Rectangle 2"/>
+          <p:cNvSpPr/>
+          <p:nvPr/>
+        </p:nvSpPr>
+        <p:spPr>
+          <a:xfrm>
+            <a:off x="731520" y="731520"/>
+            <a:ext cx="10728655" cy="5394960"/>
+          </a:xfrm>
+          <a:prstGeom prst="roundRect">
+            <a:avLst/>
+          </a:prstGeom>
+          <a:solidFill>
+            <a:srgbClr val="1A2F52"/>
+          </a:solidFill>
+          <a:ln w="25400">
+            <a:solidFill>
+              <a:srgbClr val="C5A869"/>
+            </a:solidFill>
+          </a:ln>
+        </p:spPr>
+        <p:style>
+          <a:lnRef idx="1">
+            <a:schemeClr val="accent1"/>
+          </a:lnRef>
+          <a:fillRef idx="3">
+            <a:schemeClr val="accent1"/>
+          </a:fillRef>
+          <a:effectRef idx="2">
+            <a:schemeClr val="accent1"/>
+          </a:effectRef>
+          <a:fontRef idx="minor">
+            <a:schemeClr val="lt1"/>
+          </a:fontRef>
+        </p:style>
+        <p:txBody>
+          <a:bodyPr rtlCol="0" anchor="ctr"/>
+          <a:lstStyle/>
+          <a:p>
+            <a:pPr algn="ctr"/>
+          </a:p>
+        </p:txBody>
+      </p:sp>
+      <p:pic>
+        <p:nvPicPr>
+          <p:cNvPr id="4" name="Picture 3" descr="logo-almagd-light.png"/>
+          <p:cNvPicPr>
+            <a:picLocks noChangeAspect="1"/>
+          </p:cNvPicPr>
+          <p:nvPr/>
+        </p:nvPicPr>
+        <p:blipFill>
+          <a:blip r:embed="rId2"/>
+          <a:stretch>
+            <a:fillRect/>
+          </a:stretch>
+        </p:blipFill>
+        <p:spPr>
+          <a:xfrm>
+            <a:off x="4723790" y="1051560"/>
+            <a:ext cx="2743200" cy="953691"/>
+          </a:xfrm>
+          <a:prstGeom prst="rect">
+            <a:avLst/>
+          </a:prstGeom>
+        </p:spPr>
+      </p:pic>
+      <p:sp>
+        <p:nvSpPr>
+          <p:cNvPr id="5" name="TextBox 4"/>
           <p:cNvSpPr txBox="1"/>
           <p:nvPr/>
         </p:nvSpPr>
         <p:spPr>
           <a:xfrm>
-            <a:off x="1371600" y="1463040"/>
-            <a:ext cx="9418320" cy="4389120"/>
+            <a:off x="1097280" y="2194560"/>
+            <a:ext cx="9966960" cy="3657600"/>
           </a:xfrm>
           <a:prstGeom prst="rect">
             <a:avLst/>
@@ -12705,7 +12797,7 @@
           <a:lstStyle/>
           <a:p>
             <a:pPr algn="ctr">
-              <a:defRPr sz="3000" b="1">
+              <a:defRPr sz="2800" b="1">
                 <a:solidFill>
                   <a:srgbClr val="C5A869"/>
                 </a:solidFill>
@@ -12719,7 +12811,7 @@
           <a:p>
             <a:br/>
             <a:pPr algn="ctr">
-              <a:defRPr sz="1800" b="1">
+              <a:defRPr sz="1700" b="1">
                 <a:solidFill>
                   <a:srgbClr val="FFFFFF"/>
                 </a:solidFill>
@@ -12963,8 +13055,8 @@
         </p:nvSpPr>
         <p:spPr>
           <a:xfrm>
-            <a:off x="731520" y="1554480"/>
-            <a:ext cx="5120640" cy="4114800"/>
+            <a:off x="6217920" y="1554480"/>
+            <a:ext cx="5212080" cy="4114800"/>
           </a:xfrm>
           <a:prstGeom prst="roundRect">
             <a:avLst/>
@@ -13008,8 +13100,8 @@
         </p:nvSpPr>
         <p:spPr>
           <a:xfrm>
-            <a:off x="914400" y="1691640"/>
-            <a:ext cx="4754880" cy="3749039"/>
+            <a:off x="6355080" y="1691640"/>
+            <a:ext cx="4937760" cy="3749039"/>
           </a:xfrm>
           <a:prstGeom prst="rect">
             <a:avLst/>
@@ -13022,7 +13114,7 @@
           </a:bodyPr>
           <a:lstStyle/>
           <a:p>
-            <a:pPr>
+            <a:pPr algn="r">
               <a:defRPr sz="1500" b="1">
                 <a:solidFill>
                   <a:srgbClr val="3B82F6"/>
@@ -13035,7 +13127,7 @@
             </a:r>
           </a:p>
           <a:p>
-            <a:pPr>
+            <a:pPr algn="r">
               <a:defRPr sz="1050">
                 <a:solidFill>
                   <a:srgbClr val="1E293B"/>
@@ -13048,7 +13140,7 @@
             </a:r>
           </a:p>
           <a:p>
-            <a:pPr>
+            <a:pPr algn="r">
               <a:defRPr sz="1050">
                 <a:solidFill>
                   <a:srgbClr val="1E293B"/>
@@ -13061,7 +13153,7 @@
             </a:r>
           </a:p>
           <a:p>
-            <a:pPr>
+            <a:pPr algn="r">
               <a:defRPr sz="1050">
                 <a:solidFill>
                   <a:srgbClr val="1E293B"/>
@@ -13074,7 +13166,7 @@
             </a:r>
           </a:p>
           <a:p>
-            <a:pPr>
+            <a:pPr algn="r">
               <a:defRPr sz="1050">
                 <a:solidFill>
                   <a:srgbClr val="1E293B"/>
@@ -13087,7 +13179,7 @@
             </a:r>
           </a:p>
           <a:p>
-            <a:pPr>
+            <a:pPr algn="r">
               <a:defRPr sz="1050">
                 <a:solidFill>
                   <a:srgbClr val="1E293B"/>
@@ -13100,7 +13192,7 @@
             </a:r>
           </a:p>
           <a:p>
-            <a:pPr>
+            <a:pPr algn="r">
               <a:defRPr sz="1050">
                 <a:solidFill>
                   <a:srgbClr val="E11D48"/>
@@ -13113,7 +13205,7 @@
             </a:r>
           </a:p>
           <a:p>
-            <a:pPr>
+            <a:pPr algn="r">
               <a:defRPr sz="1050">
                 <a:solidFill>
                   <a:srgbClr val="E11D48"/>
@@ -13135,7 +13227,7 @@
         </p:nvSpPr>
         <p:spPr>
           <a:xfrm>
-            <a:off x="6217920" y="1554480"/>
+            <a:off x="731520" y="1554480"/>
             <a:ext cx="5212080" cy="4114800"/>
           </a:xfrm>
           <a:prstGeom prst="roundRect">
@@ -13180,8 +13272,8 @@
         </p:nvSpPr>
         <p:spPr>
           <a:xfrm>
-            <a:off x="6400800" y="1691640"/>
-            <a:ext cx="4846320" cy="3749039"/>
+            <a:off x="868680" y="1691640"/>
+            <a:ext cx="4937760" cy="3749039"/>
           </a:xfrm>
           <a:prstGeom prst="rect">
             <a:avLst/>
@@ -13194,7 +13286,7 @@
           </a:bodyPr>
           <a:lstStyle/>
           <a:p>
-            <a:pPr>
+            <a:pPr algn="r">
               <a:defRPr sz="1500" b="1">
                 <a:solidFill>
                   <a:srgbClr val="A3864B"/>
@@ -13207,7 +13299,7 @@
             </a:r>
           </a:p>
           <a:p>
-            <a:pPr>
+            <a:pPr algn="r">
               <a:defRPr sz="1050">
                 <a:solidFill>
                   <a:srgbClr val="1E293B"/>
@@ -13220,7 +13312,7 @@
             </a:r>
           </a:p>
           <a:p>
-            <a:pPr>
+            <a:pPr algn="r">
               <a:defRPr sz="1050">
                 <a:solidFill>
                   <a:srgbClr val="1E293B"/>
@@ -13233,7 +13325,7 @@
             </a:r>
           </a:p>
           <a:p>
-            <a:pPr>
+            <a:pPr algn="r">
               <a:defRPr sz="1050">
                 <a:solidFill>
                   <a:srgbClr val="1E293B"/>
@@ -13246,7 +13338,7 @@
             </a:r>
           </a:p>
           <a:p>
-            <a:pPr>
+            <a:pPr algn="r">
               <a:defRPr sz="1050">
                 <a:solidFill>
                   <a:srgbClr val="1E293B"/>
@@ -13259,7 +13351,7 @@
             </a:r>
           </a:p>
           <a:p>
-            <a:pPr>
+            <a:pPr algn="r">
               <a:defRPr sz="1050">
                 <a:solidFill>
                   <a:srgbClr val="1E293B"/>
@@ -13272,7 +13364,7 @@
             </a:r>
           </a:p>
           <a:p>
-            <a:pPr>
+            <a:pPr algn="r">
               <a:defRPr sz="1050">
                 <a:solidFill>
                   <a:srgbClr val="1E293B"/>
@@ -13285,7 +13377,7 @@
             </a:r>
           </a:p>
           <a:p>
-            <a:pPr>
+            <a:pPr algn="r">
               <a:defRPr sz="1050">
                 <a:solidFill>
                   <a:srgbClr val="1E293B"/>

</xml_diff>

<commit_message>
docs: add 5-section new booking guide with live screenshot of payment input to manual and presentation
</commit_message>
<xml_diff>
--- a/ALMAGD_PMS_Visual_Master_Presentation.pptx
+++ b/ALMAGD_PMS_Visual_Master_Presentation.pptx
@@ -14799,7 +14799,7 @@
               </a:defRPr>
             </a:pPr>
             <a:r>
-              <a:t>الحجز المباشر للنزلاء الجدد (Direct Walk-in)</a:t>
+              <a:t>شرح الحقول الخمسة في نموذج الحجز وإدخال الدفعة الأولى</a:t>
             </a:r>
           </a:p>
         </p:txBody>
@@ -14923,7 +14923,7 @@
               </a:defRPr>
             </a:pPr>
             <a:r>
-              <a:t>السيناريو رقم 1</a:t>
+              <a:t>السيناريو رقم 1 (New Booking &amp; 5 Cards)</a:t>
             </a:r>
           </a:p>
           <a:p>
@@ -14936,7 +14936,7 @@
               </a:defRPr>
             </a:pPr>
             <a:r>
-              <a:t>📌 الحالة: ضيف يصل للاستقبال بدون حجز مسبق، أو يتواصل هاتفياً/واتساب ويريد الإقامة في فيلا أو غرفة مستقلة.</a:t>
+              <a:t>📌 الحالة: تسجيل حجز جديد مع ضبط البيانات الإلزامية الخمسة وإدخال الدفعة الأولى وضبط الرصيد المتبقي.</a:t>
             </a:r>
           </a:p>
           <a:p>
@@ -14963,7 +14963,7 @@
               </a:defRPr>
             </a:pPr>
             <a:r>
-              <a:t>[1] فتح نموذج الحجز</a:t>
+              <a:t>[1] 1 &amp; 2. الضيف والتواريخ</a:t>
             </a:r>
           </a:p>
           <a:p>
@@ -14976,7 +14976,7 @@
               </a:defRPr>
             </a:pPr>
             <a:r>
-              <a:t>     الضغط على «الحجوزات» ثم «+ حجز جديد» في أعلى الشاشة.</a:t>
+              <a:t>     تحديد هوية النزيل وتاريخ الوصول والمغادرة وعدد الأفراد وحساب الليالي آلياً.</a:t>
             </a:r>
           </a:p>
           <a:p>
@@ -14989,7 +14989,7 @@
               </a:defRPr>
             </a:pPr>
             <a:r>
-              <a:t>[2] إدخال بيانات الضيف والتواريخ</a:t>
+              <a:t>[2] 3. الوحدة الشاغرة</a:t>
             </a:r>
           </a:p>
           <a:p>
@@ -15002,7 +15002,7 @@
               </a:defRPr>
             </a:pPr>
             <a:r>
-              <a:t>     كتابة اسم الضيف، رقم هاتفه، تاريخ الوصول وتاريخ المغادرة وعدد الليالي.</a:t>
+              <a:t>     يعرض النظام الوحدات المتاحة فعلياً فقط ويمنع بيع الغرف المشغولة لمنع التضارب.</a:t>
             </a:r>
           </a:p>
           <a:p>
@@ -15015,7 +15015,7 @@
               </a:defRPr>
             </a:pPr>
             <a:r>
-              <a:t>[3] اختيار الوحدة الشاغرة</a:t>
+              <a:t>[3] 4. الإجمالي والمصدر</a:t>
             </a:r>
           </a:p>
           <a:p>
@@ -15028,7 +15028,7 @@
               </a:defRPr>
             </a:pPr>
             <a:r>
-              <a:t>     يعرض النظام الوحدات المتاحة فعلياً فقط ويمنع بيع الغرف المشغولة لمنع التضارب.</a:t>
+              <a:t>     تحديد نمط السعر، ومصدر الحجز (Walk-in أو كود المنصة في خانة OTA Reference).</a:t>
             </a:r>
           </a:p>
           <a:p>
@@ -15041,7 +15041,7 @@
               </a:defRPr>
             </a:pPr>
             <a:r>
-              <a:t>[4] تسجيل الدفعة الأولى والحفظ</a:t>
+              <a:t>[4] 5. الدفعة الأولى والرصيد</a:t>
             </a:r>
           </a:p>
           <a:p>
@@ -15054,7 +15054,7 @@
               </a:defRPr>
             </a:pPr>
             <a:r>
-              <a:t>     تحديد المصدر (Walk-in)، وإدخال المبلغ المقبوض كاش أو تحويل، ثم الضغط على «إنشاء الحجز».</a:t>
+              <a:t>     تفعيل الدفعة وتحديد الطريقة (نقداً/تحويل/تطبيق) لضبط الرصيد وظهور شارة خالص ✓.</a:t>
             </a:r>
           </a:p>
         </p:txBody>
@@ -15142,7 +15142,7 @@
       </p:sp>
       <p:pic>
         <p:nvPicPr>
-          <p:cNvPr id="10" name="Picture 9" descr="shot_04_new_booking.png"/>
+          <p:cNvPr id="10" name="Picture 9" descr="shot_04b_payment_focused.png"/>
           <p:cNvPicPr>
             <a:picLocks noChangeAspect="1"/>
           </p:cNvPicPr>
@@ -15238,7 +15238,7 @@
               </a:defRPr>
             </a:pPr>
             <a:r>
-              <a:t>💡 قاعدة تشغيلية هامة للاستقبال: كل حجز يتم حفظه يُقفل الغرفة لحظياً في قاعدة البيانات ولا مجال لحدوث أي تضارب.</a:t>
+              <a:t>💡 قاعدة تشغيلية هامة للاستقبال: تسجيل الدفعة الأولى في القسم 5 يضبط رصيد الحجز فوراً ويمنع أي عجز في صندوق الاستقبال.</a:t>
             </a:r>
           </a:p>
         </p:txBody>

</xml_diff>

<commit_message>
docs: improve RTL step numbering alignment in master presentation
</commit_message>
<xml_diff>
--- a/ALMAGD_PMS_Visual_Master_Presentation.pptx
+++ b/ALMAGD_PMS_Visual_Master_Presentation.pptx
@@ -3611,7 +3611,7 @@
               </a:defRPr>
             </a:pPr>
             <a:r>
-              <a:t>[1] الدخول على تفاصيل الحجز</a:t>
+              <a:t>الخطوة 1: الدخول على تفاصيل الحجز</a:t>
             </a:r>
           </a:p>
           <a:p>
@@ -3637,7 +3637,7 @@
               </a:defRPr>
             </a:pPr>
             <a:r>
-              <a:t>[2] معاينة السند الرسمي</a:t>
+              <a:t>الخطوة 2: معاينة السند الرسمي</a:t>
             </a:r>
           </a:p>
           <a:p>
@@ -3663,7 +3663,7 @@
               </a:defRPr>
             </a:pPr>
             <a:r>
-              <a:t>[3] أمر الطباعة المباشر</a:t>
+              <a:t>الخطوة 3: أمر الطباعة المباشر</a:t>
             </a:r>
           </a:p>
           <a:p>
@@ -3689,7 +3689,7 @@
               </a:defRPr>
             </a:pPr>
             <a:r>
-              <a:t>[4] الحفظ كـ PDF أو الطباعة الورقية</a:t>
+              <a:t>الخطوة 4: الحفظ كـ PDF أو الطباعة الورقية</a:t>
             </a:r>
           </a:p>
           <a:p>
@@ -4202,7 +4202,7 @@
               </a:defRPr>
             </a:pPr>
             <a:r>
-              <a:t>[1] التعرف على بادج المنصة الأزرق</a:t>
+              <a:t>الخطوة 1: التعرف على بادج المنصة الأزرق</a:t>
             </a:r>
           </a:p>
           <a:p>
@@ -4228,7 +4228,7 @@
               </a:defRPr>
             </a:pPr>
             <a:r>
-              <a:t>[2] التحقق من الرصيد المطلوب</a:t>
+              <a:t>الخطوة 2: التحقق من الرصيد المطلوب</a:t>
             </a:r>
           </a:p>
           <a:p>
@@ -4254,7 +4254,7 @@
               </a:defRPr>
             </a:pPr>
             <a:r>
-              <a:t>[3] استقبال النزيل دون طلب أموال</a:t>
+              <a:t>الخطوة 3: استقبال النزيل دون طلب أموال</a:t>
             </a:r>
           </a:p>
           <a:p>
@@ -4280,7 +4280,7 @@
               </a:defRPr>
             </a:pPr>
             <a:r>
-              <a:t>[4] منع تسجيل كاش وهمي</a:t>
+              <a:t>الخطوة 4: منع تسجيل كاش وهمي</a:t>
             </a:r>
           </a:p>
           <a:p>
@@ -4793,7 +4793,7 @@
               </a:defRPr>
             </a:pPr>
             <a:r>
-              <a:t>[1] فهم سياسة تحويلات المنصات</a:t>
+              <a:t>الخطوة 1: فهم سياسة تحويلات المنصات</a:t>
             </a:r>
           </a:p>
           <a:p>
@@ -4819,7 +4819,7 @@
               </a:defRPr>
             </a:pPr>
             <a:r>
-              <a:t>[2] قراءة مؤشر المدة في النظام</a:t>
+              <a:t>الخطوة 2: قراءة مؤشر المدة في النظام</a:t>
             </a:r>
           </a:p>
           <a:p>
@@ -4845,7 +4845,7 @@
               </a:defRPr>
             </a:pPr>
             <a:r>
-              <a:t>[3] توضيح طبيعة المبلغ</a:t>
+              <a:t>الخطوة 3: توضيح طبيعة المبلغ</a:t>
             </a:r>
           </a:p>
           <a:p>
@@ -4871,7 +4871,7 @@
               </a:defRPr>
             </a:pPr>
             <a:r>
-              <a:t>[4] حماية كاش اليومية</a:t>
+              <a:t>الخطوة 4: حماية كاش اليومية</a:t>
             </a:r>
           </a:p>
           <a:p>
@@ -5384,7 +5384,7 @@
               </a:defRPr>
             </a:pPr>
             <a:r>
-              <a:t>[1] الضغط على زر تمديد الإقامة</a:t>
+              <a:t>الخطوة 1: الضغط على زر تمديد الإقامة</a:t>
             </a:r>
           </a:p>
           <a:p>
@@ -5410,7 +5410,7 @@
               </a:defRPr>
             </a:pPr>
             <a:r>
-              <a:t>[2] اختيار عدد الليالي السريعة</a:t>
+              <a:t>الخطوة 2: اختيار عدد الليالي السريعة</a:t>
             </a:r>
           </a:p>
           <a:p>
@@ -5436,7 +5436,7 @@
               </a:defRPr>
             </a:pPr>
             <a:r>
-              <a:t>[3] الفحص التلقائي للشغور</a:t>
+              <a:t>الخطوة 3: الفحص التلقائي للشغور</a:t>
             </a:r>
           </a:p>
           <a:p>
@@ -5462,7 +5462,7 @@
               </a:defRPr>
             </a:pPr>
             <a:r>
-              <a:t>[4] حساب السعر الإضافي وتأكيد التمديد</a:t>
+              <a:t>الخطوة 4: حساب السعر الإضافي وتأكيد التمديد</a:t>
             </a:r>
           </a:p>
           <a:p>
@@ -5975,7 +5975,7 @@
               </a:defRPr>
             </a:pPr>
             <a:r>
-              <a:t>[1] الضغط على زر مغادرة مبكرة</a:t>
+              <a:t>الخطوة 1: الضغط على زر مغادرة مبكرة</a:t>
             </a:r>
           </a:p>
           <a:p>
@@ -6001,7 +6001,7 @@
               </a:defRPr>
             </a:pPr>
             <a:r>
-              <a:t>[2] احتساب الليالي الفعلية تلقائياً</a:t>
+              <a:t>الخطوة 2: احتساب الليالي الفعلية تلقائياً</a:t>
             </a:r>
           </a:p>
           <a:p>
@@ -6027,7 +6027,7 @@
               </a:defRPr>
             </a:pPr>
             <a:r>
-              <a:t>[3] اختيار سياسة التسوية المالية</a:t>
+              <a:t>الخطوة 3: اختيار سياسة التسوية المالية</a:t>
             </a:r>
           </a:p>
           <a:p>
@@ -6053,7 +6053,7 @@
               </a:defRPr>
             </a:pPr>
             <a:r>
-              <a:t>[4] تسجيل سند الاسترداد وإخلاء الغرفة</a:t>
+              <a:t>الخطوة 4: تسجيل سند الاسترداد وإخلاء الغرفة</a:t>
             </a:r>
           </a:p>
           <a:p>
@@ -6566,7 +6566,7 @@
               </a:defRPr>
             </a:pPr>
             <a:r>
-              <a:t>[1] الضغط على زر نقل الوحدة</a:t>
+              <a:t>الخطوة 1: الضغط على زر نقل الوحدة</a:t>
             </a:r>
           </a:p>
           <a:p>
@@ -6592,7 +6592,7 @@
               </a:defRPr>
             </a:pPr>
             <a:r>
-              <a:t>[2] عرض البدائل الشاغرة فقط</a:t>
+              <a:t>الخطوة 2: عرض البدائل الشاغرة فقط</a:t>
             </a:r>
           </a:p>
           <a:p>
@@ -6618,7 +6618,7 @@
               </a:defRPr>
             </a:pPr>
             <a:r>
-              <a:t>[3] اختيار سياسة التسعير</a:t>
+              <a:t>الخطوة 3: اختيار سياسة التسعير</a:t>
             </a:r>
           </a:p>
           <a:p>
@@ -6644,7 +6644,7 @@
               </a:defRPr>
             </a:pPr>
             <a:r>
-              <a:t>[4] تسجيل سبب النقل والتأكيد</a:t>
+              <a:t>الخطوة 4: تسجيل سبب النقل والتأكيد</a:t>
             </a:r>
           </a:p>
           <a:p>
@@ -7157,7 +7157,7 @@
               </a:defRPr>
             </a:pPr>
             <a:r>
-              <a:t>[1] تسجيل الدفعة الأولى (عربون بنكي)</a:t>
+              <a:t>الخطوة 1: تسجيل الدفعة الأولى (عربون بنكي)</a:t>
             </a:r>
           </a:p>
           <a:p>
@@ -7183,7 +7183,7 @@
               </a:defRPr>
             </a:pPr>
             <a:r>
-              <a:t>[2] تسجيل الدفعة الثانية (كاش عند الدخول)</a:t>
+              <a:t>الخطوة 2: تسجيل الدفعة الثانية (كاش عند الدخول)</a:t>
             </a:r>
           </a:p>
           <a:p>
@@ -7209,7 +7209,7 @@
               </a:defRPr>
             </a:pPr>
             <a:r>
-              <a:t>[3] تسجيل الدفعة الثالثة (تصفية الحساب)</a:t>
+              <a:t>الخطوة 3: تسجيل الدفعة الثالثة (تصفية الحساب)</a:t>
             </a:r>
           </a:p>
           <a:p>
@@ -7235,7 +7235,7 @@
               </a:defRPr>
             </a:pPr>
             <a:r>
-              <a:t>[4] طباعة الإيصال النهائي المجمع</a:t>
+              <a:t>الخطوة 4: طباعة الإيصال النهائي المجمع</a:t>
             </a:r>
           </a:p>
           <a:p>
@@ -7748,7 +7748,7 @@
               </a:defRPr>
             </a:pPr>
             <a:r>
-              <a:t>[1] الضغط على زر إلغاء الحجز</a:t>
+              <a:t>الخطوة 1: الضغط على زر إلغاء الحجز</a:t>
             </a:r>
           </a:p>
           <a:p>
@@ -7774,7 +7774,7 @@
               </a:defRPr>
             </a:pPr>
             <a:r>
-              <a:t>[2] اختيار سياسة خصم غرامة فندقية</a:t>
+              <a:t>الخطوة 2: اختيار سياسة خصم غرامة فندقية</a:t>
             </a:r>
           </a:p>
           <a:p>
@@ -7800,7 +7800,7 @@
               </a:defRPr>
             </a:pPr>
             <a:r>
-              <a:t>[3] إدخال مبلغ الغرامة المستقطع</a:t>
+              <a:t>الخطوة 3: إدخال مبلغ الغرامة المستقطع</a:t>
             </a:r>
           </a:p>
           <a:p>
@@ -7826,7 +7826,7 @@
               </a:defRPr>
             </a:pPr>
             <a:r>
-              <a:t>[4] تعديل قيمة الحجز واعتماد الإيراد</a:t>
+              <a:t>الخطوة 4: تعديل قيمة الحجز واعتماد الإيراد</a:t>
             </a:r>
           </a:p>
           <a:p>
@@ -8339,7 +8339,7 @@
               </a:defRPr>
             </a:pPr>
             <a:r>
-              <a:t>[1] الضغط على زر لم يحضر</a:t>
+              <a:t>الخطوة 1: الضغط على زر لم يحضر</a:t>
             </a:r>
           </a:p>
           <a:p>
@@ -8365,7 +8365,7 @@
               </a:defRPr>
             </a:pPr>
             <a:r>
-              <a:t>[2] اختيار مصادرة كامل المبلغ</a:t>
+              <a:t>الخطوة 2: اختيار مصادرة كامل المبلغ</a:t>
             </a:r>
           </a:p>
           <a:p>
@@ -8391,7 +8391,7 @@
               </a:defRPr>
             </a:pPr>
             <a:r>
-              <a:t>[3] اعتماد الغرامة بالكامل</a:t>
+              <a:t>الخطوة 3: اعتماد الغرامة بالكامل</a:t>
             </a:r>
           </a:p>
           <a:p>
@@ -8417,7 +8417,7 @@
               </a:defRPr>
             </a:pPr>
             <a:r>
-              <a:t>[4] تحرير الغرفة للبيع الفوري</a:t>
+              <a:t>الخطوة 4: تحرير الغرفة للبيع الفوري</a:t>
             </a:r>
           </a:p>
           <a:p>
@@ -8930,7 +8930,7 @@
               </a:defRPr>
             </a:pPr>
             <a:r>
-              <a:t>[1] التحول التلقائي بعد المغادرة (س 19)</a:t>
+              <a:t>الخطوة 1: التحول التلقائي بعد المغادرة (س 19)</a:t>
             </a:r>
           </a:p>
           <a:p>
@@ -8956,7 +8956,7 @@
               </a:defRPr>
             </a:pPr>
             <a:r>
-              <a:t>[2] بدء تنظيف الغرفة بواسطة العامل</a:t>
+              <a:t>الخطوة 2: بدء تنظيف الغرفة بواسطة العامل</a:t>
             </a:r>
           </a:p>
           <a:p>
@@ -8982,7 +8982,7 @@
               </a:defRPr>
             </a:pPr>
             <a:r>
-              <a:t>[3] اكتمال النظافة والفحص (س 20)</a:t>
+              <a:t>الخطوة 3: اكتمال النظافة والفحص (س 20)</a:t>
             </a:r>
           </a:p>
           <a:p>
@@ -9008,7 +9008,7 @@
               </a:defRPr>
             </a:pPr>
             <a:r>
-              <a:t>[4] لوحة النظافة في شاشة اليوم</a:t>
+              <a:t>الخطوة 4: لوحة النظافة في شاشة اليوم</a:t>
             </a:r>
           </a:p>
           <a:p>
@@ -10365,7 +10365,7 @@
               </a:defRPr>
             </a:pPr>
             <a:r>
-              <a:t>[1] حجز الفيلا بالكامل (Master Villa)</a:t>
+              <a:t>الخطوة 1: حجز الفيلا بالكامل (Master Villa)</a:t>
             </a:r>
           </a:p>
           <a:p>
@@ -10391,7 +10391,7 @@
               </a:defRPr>
             </a:pPr>
             <a:r>
-              <a:t>[2] حجز غرفة واحدة داخل الفيلا</a:t>
+              <a:t>الخطوة 2: حجز غرفة واحدة داخل الفيلا</a:t>
             </a:r>
           </a:p>
           <a:p>
@@ -10417,7 +10417,7 @@
               </a:defRPr>
             </a:pPr>
             <a:r>
-              <a:t>[3] إتاحة الغرف المتبقية فقط</a:t>
+              <a:t>الخطوة 3: إتاحة الغرف المتبقية فقط</a:t>
             </a:r>
           </a:p>
           <a:p>
@@ -10443,7 +10443,7 @@
               </a:defRPr>
             </a:pPr>
             <a:r>
-              <a:t>[4] عرض التقويم التفاعلي بـ 96 وحدة</a:t>
+              <a:t>الخطوة 4: عرض التقويم التفاعلي بـ 96 وحدة</a:t>
             </a:r>
           </a:p>
           <a:p>
@@ -10956,7 +10956,7 @@
               </a:defRPr>
             </a:pPr>
             <a:r>
-              <a:t>[1] الدخول على إعدادات الصيانة</a:t>
+              <a:t>الخطوة 1: الدخول على إعدادات الصيانة</a:t>
             </a:r>
           </a:p>
           <a:p>
@@ -10982,7 +10982,7 @@
               </a:defRPr>
             </a:pPr>
             <a:r>
-              <a:t>[2] إضافة إغلاق صيانة جديد</a:t>
+              <a:t>الخطوة 2: إضافة إغلاق صيانة جديد</a:t>
             </a:r>
           </a:p>
           <a:p>
@@ -11008,7 +11008,7 @@
               </a:defRPr>
             </a:pPr>
             <a:r>
-              <a:t>[3] تحديد فترة الصيانة والسبب</a:t>
+              <a:t>الخطوة 3: تحديد فترة الصيانة والسبب</a:t>
             </a:r>
           </a:p>
           <a:p>
@@ -11034,7 +11034,7 @@
               </a:defRPr>
             </a:pPr>
             <a:r>
-              <a:t>[4] حظر الوحدة من البيع آلياً</a:t>
+              <a:t>الخطوة 4: حظر الوحدة من البيع آلياً</a:t>
             </a:r>
           </a:p>
           <a:p>
@@ -11547,7 +11547,7 @@
               </a:defRPr>
             </a:pPr>
             <a:r>
-              <a:t>[1] شريط التنبيهات الأحمر العاجل</a:t>
+              <a:t>الخطوة 1: شريط التنبيهات الأحمر العاجل</a:t>
             </a:r>
           </a:p>
           <a:p>
@@ -11573,7 +11573,7 @@
               </a:defRPr>
             </a:pPr>
             <a:r>
-              <a:t>[2] حالة تجاوز موعد المغادرة</a:t>
+              <a:t>الخطوة 2: حالة تجاوز موعد المغادرة</a:t>
             </a:r>
           </a:p>
           <a:p>
@@ -11599,7 +11599,7 @@
               </a:defRPr>
             </a:pPr>
             <a:r>
-              <a:t>[3] حالة التأخر عن تسجيل الدخول</a:t>
+              <a:t>الخطوة 3: حالة التأخر عن تسجيل الدخول</a:t>
             </a:r>
           </a:p>
           <a:p>
@@ -11625,7 +11625,7 @@
               </a:defRPr>
             </a:pPr>
             <a:r>
-              <a:t>[4] حسم التنبيه بنقرة زر</a:t>
+              <a:t>الخطوة 4: حسم التنبيه بنقرة زر</a:t>
             </a:r>
           </a:p>
           <a:p>
@@ -12138,7 +12138,7 @@
               </a:defRPr>
             </a:pPr>
             <a:r>
-              <a:t>[1] فحص كرت المقبوضات في لوحة المدير</a:t>
+              <a:t>الخطوة 1: فحص كرت المقبوضات في لوحة المدير</a:t>
             </a:r>
           </a:p>
           <a:p>
@@ -12164,7 +12164,7 @@
               </a:defRPr>
             </a:pPr>
             <a:r>
-              <a:t>[2] مطابقة النقد الفعلي في الدرج</a:t>
+              <a:t>الخطوة 2: مطابقة النقد الفعلي في الدرج</a:t>
             </a:r>
           </a:p>
           <a:p>
@@ -12190,7 +12190,7 @@
               </a:defRPr>
             </a:pPr>
             <a:r>
-              <a:t>[3] تصدير التقرير اليومي الشامل للإكسل</a:t>
+              <a:t>الخطوة 3: تصدير التقرير اليومي الشامل للإكسل</a:t>
             </a:r>
           </a:p>
           <a:p>
@@ -12216,7 +12216,7 @@
               </a:defRPr>
             </a:pPr>
             <a:r>
-              <a:t>[4] مشاركة التقرير مع الإدارة والمحاسب</a:t>
+              <a:t>الخطوة 4: مشاركة التقرير مع الإدارة والمحاسب</a:t>
             </a:r>
           </a:p>
           <a:p>
@@ -13781,7 +13781,7 @@
               </a:defRPr>
             </a:pPr>
             <a:r>
-              <a:t>[1] الوصول للرابط الرسمي</a:t>
+              <a:t>الخطوة 1: الوصول للرابط الرسمي</a:t>
             </a:r>
           </a:p>
           <a:p>
@@ -13807,7 +13807,7 @@
               </a:defRPr>
             </a:pPr>
             <a:r>
-              <a:t>[2] إدخال البريد الإلكتروني</a:t>
+              <a:t>الخطوة 2: إدخال البريد الإلكتروني</a:t>
             </a:r>
           </a:p>
           <a:p>
@@ -13833,7 +13833,7 @@
               </a:defRPr>
             </a:pPr>
             <a:r>
-              <a:t>[3] إدخال كلمة المرور المشفرة</a:t>
+              <a:t>الخطوة 3: إدخال كلمة المرور المشفرة</a:t>
             </a:r>
           </a:p>
           <a:p>
@@ -13859,7 +13859,7 @@
               </a:defRPr>
             </a:pPr>
             <a:r>
-              <a:t>[4] التحويل التلقائي للوحة العمليات</a:t>
+              <a:t>الخطوة 4: التحويل التلقائي للوحة العمليات</a:t>
             </a:r>
           </a:p>
           <a:p>
@@ -14372,7 +14372,7 @@
               </a:defRPr>
             </a:pPr>
             <a:r>
-              <a:t>[1] متابعة بطاقات الإشغال الـ 4</a:t>
+              <a:t>الخطوة 1: متابعة بطاقات الإشغال الـ 4</a:t>
             </a:r>
           </a:p>
           <a:p>
@@ -14398,7 +14398,7 @@
               </a:defRPr>
             </a:pPr>
             <a:r>
-              <a:t>[2] شريط النظافة الفوري (Housekeeping)</a:t>
+              <a:t>الخطوة 2: شريط النظافة الفوري (Housekeeping)</a:t>
             </a:r>
           </a:p>
           <a:p>
@@ -14424,7 +14424,7 @@
               </a:defRPr>
             </a:pPr>
             <a:r>
-              <a:t>[3] كشف القدوم والمغادرة</a:t>
+              <a:t>الخطوة 3: كشف القدوم والمغادرة</a:t>
             </a:r>
           </a:p>
           <a:p>
@@ -14450,7 +14450,7 @@
               </a:defRPr>
             </a:pPr>
             <a:r>
-              <a:t>[4] فلترة الفلل والغرف المشغولة</a:t>
+              <a:t>الخطوة 4: فلترة الفلل والغرف المشغولة</a:t>
             </a:r>
           </a:p>
           <a:p>
@@ -14963,7 +14963,7 @@
               </a:defRPr>
             </a:pPr>
             <a:r>
-              <a:t>[1] 1 &amp; 2. الضيف والتواريخ</a:t>
+              <a:t>الخطوة 1: 1 &amp; 2. الضيف والتواريخ</a:t>
             </a:r>
           </a:p>
           <a:p>
@@ -14989,7 +14989,7 @@
               </a:defRPr>
             </a:pPr>
             <a:r>
-              <a:t>[2] 3. الوحدة الشاغرة</a:t>
+              <a:t>الخطوة 2: 3. الوحدة الشاغرة</a:t>
             </a:r>
           </a:p>
           <a:p>
@@ -15015,7 +15015,7 @@
               </a:defRPr>
             </a:pPr>
             <a:r>
-              <a:t>[3] 4. الإجمالي والمصدر</a:t>
+              <a:t>الخطوة 3: 4. الإجمالي والمصدر</a:t>
             </a:r>
           </a:p>
           <a:p>
@@ -15041,7 +15041,7 @@
               </a:defRPr>
             </a:pPr>
             <a:r>
-              <a:t>[4] 5. الدفعة الأولى والرصيد</a:t>
+              <a:t>الخطوة 4: 5. الدفعة الأولى والرصيد</a:t>
             </a:r>
           </a:p>
           <a:p>
@@ -15554,7 +15554,7 @@
               </a:defRPr>
             </a:pPr>
             <a:r>
-              <a:t>[1] البحث السريع عن الضيف</a:t>
+              <a:t>الخطوة 1: البحث السريع عن الضيف</a:t>
             </a:r>
           </a:p>
           <a:p>
@@ -15580,7 +15580,7 @@
               </a:defRPr>
             </a:pPr>
             <a:r>
-              <a:t>[2] استدعاء الملف والوسام</a:t>
+              <a:t>الخطوة 2: استدعاء الملف والوسام</a:t>
             </a:r>
           </a:p>
           <a:p>
@@ -15606,7 +15606,7 @@
               </a:defRPr>
             </a:pPr>
             <a:r>
-              <a:t>[3] اختيار الضيف بنقرة واحدة</a:t>
+              <a:t>الخطوة 3: اختيار الضيف بنقرة واحدة</a:t>
             </a:r>
           </a:p>
           <a:p>
@@ -15632,7 +15632,7 @@
               </a:defRPr>
             </a:pPr>
             <a:r>
-              <a:t>[4] إتمام الحجز</a:t>
+              <a:t>الخطوة 4: إتمام الحجز</a:t>
             </a:r>
           </a:p>
           <a:p>
@@ -16145,7 +16145,7 @@
               </a:defRPr>
             </a:pPr>
             <a:r>
-              <a:t>[1] فحص نظافة الغرفة أولاً</a:t>
+              <a:t>الخطوة 1: فحص نظافة الغرفة أولاً</a:t>
             </a:r>
           </a:p>
           <a:p>
@@ -16171,7 +16171,7 @@
               </a:defRPr>
             </a:pPr>
             <a:r>
-              <a:t>[2] تسجيل الوصول (Check-in)</a:t>
+              <a:t>الخطوة 2: تسجيل الوصول (Check-in)</a:t>
             </a:r>
           </a:p>
           <a:p>
@@ -16197,7 +16197,7 @@
               </a:defRPr>
             </a:pPr>
             <a:r>
-              <a:t>[3] فحص الرصيد عند المغادرة</a:t>
+              <a:t>الخطوة 3: فحص الرصيد عند المغادرة</a:t>
             </a:r>
           </a:p>
           <a:p>
@@ -16223,7 +16223,7 @@
               </a:defRPr>
             </a:pPr>
             <a:r>
-              <a:t>[4] تسجيل المغادرة (Check-out)</a:t>
+              <a:t>الخطوة 4: تسجيل المغادرة (Check-out)</a:t>
             </a:r>
           </a:p>
           <a:p>
@@ -16736,7 +16736,7 @@
               </a:defRPr>
             </a:pPr>
             <a:r>
-              <a:t>[1] محاولة الضغط على مغادرة</a:t>
+              <a:t>الخطوة 1: محاولة الضغط على مغادرة</a:t>
             </a:r>
           </a:p>
           <a:p>
@@ -16762,7 +16762,7 @@
               </a:defRPr>
             </a:pPr>
             <a:r>
-              <a:t>[2] ظهور التنبيه التحذيري الأحمر ⚠️</a:t>
+              <a:t>الخطوة 2: ظهور التنبيه التحذيري الأحمر ⚠️</a:t>
             </a:r>
           </a:p>
           <a:p>
@@ -16788,7 +16788,7 @@
               </a:defRPr>
             </a:pPr>
             <a:r>
-              <a:t>[3] تحصيل المبلغ من النزيل</a:t>
+              <a:t>الخطوة 3: تحصيل المبلغ من النزيل</a:t>
             </a:r>
           </a:p>
           <a:p>
@@ -16814,7 +16814,7 @@
               </a:defRPr>
             </a:pPr>
             <a:r>
-              <a:t>[4] تسجيل الدفعة وإتمام الخروج</a:t>
+              <a:t>الخطوة 4: تسجيل الدفعة وإتمام الخروج</a:t>
             </a:r>
           </a:p>
           <a:p>

</xml_diff>